<commit_message>
Revise M1 slides to present student ideas and creative progress
</commit_message>
<xml_diff>
--- a/m1-world/m1-簡報.pptx
+++ b/m1-world/m1-簡報.pptx
@@ -2,18 +2,18 @@
 <file path=ppt/presentation.xml><?xml version="1.0" encoding="utf-8"?>
 <p:presentation xmlns:p="http://schemas.openxmlformats.org/presentationml/2006/main">
   <p:sldMasterIdLst>
-    <p:sldMasterId xmlns:r="http://schemas.openxmlformats.org/officeDocument/2006/relationships" id="2147483648" r:id="Re9a0c7a8daec4fa3"/>
+    <p:sldMasterId xmlns:r="http://schemas.openxmlformats.org/officeDocument/2006/relationships" id="2147483648" r:id="R37d70cb50eb841bb"/>
   </p:sldMasterIdLst>
   <p:notesMasterIdLst>
-    <p:notesMasterId xmlns:r="http://schemas.openxmlformats.org/officeDocument/2006/relationships" r:id="R6127fcd9120e46f0"/>
+    <p:notesMasterId xmlns:r="http://schemas.openxmlformats.org/officeDocument/2006/relationships" r:id="Rb4b3617355b247ea"/>
   </p:notesMasterIdLst>
   <p:sldIdLst>
-    <p:sldId xmlns:r="http://schemas.openxmlformats.org/officeDocument/2006/relationships" id="256" r:id="Rc0d64c9e33b74434"/>
-    <p:sldId xmlns:r="http://schemas.openxmlformats.org/officeDocument/2006/relationships" id="257" r:id="Rad036243e2b84e46"/>
-    <p:sldId xmlns:r="http://schemas.openxmlformats.org/officeDocument/2006/relationships" id="258" r:id="R4103cdd6d4d7455b"/>
-    <p:sldId xmlns:r="http://schemas.openxmlformats.org/officeDocument/2006/relationships" id="259" r:id="R686480f26eab47fe"/>
-    <p:sldId xmlns:r="http://schemas.openxmlformats.org/officeDocument/2006/relationships" id="260" r:id="R7c28ca9969f04959"/>
-    <p:sldId xmlns:r="http://schemas.openxmlformats.org/officeDocument/2006/relationships" id="261" r:id="R1c692f9efc884495"/>
+    <p:sldId xmlns:r="http://schemas.openxmlformats.org/officeDocument/2006/relationships" id="256" r:id="R3ca456f5ed2e41ca"/>
+    <p:sldId xmlns:r="http://schemas.openxmlformats.org/officeDocument/2006/relationships" id="257" r:id="Rd823f2442f4a414b"/>
+    <p:sldId xmlns:r="http://schemas.openxmlformats.org/officeDocument/2006/relationships" id="258" r:id="Rc0b8aea9f13848ad"/>
+    <p:sldId xmlns:r="http://schemas.openxmlformats.org/officeDocument/2006/relationships" id="259" r:id="R2e83ebf1cc8343eb"/>
+    <p:sldId xmlns:r="http://schemas.openxmlformats.org/officeDocument/2006/relationships" id="260" r:id="Rb5c2db34d5284693"/>
+    <p:sldId xmlns:r="http://schemas.openxmlformats.org/officeDocument/2006/relationships" id="261" r:id="Rc8792df3c2e04bf4"/>
   </p:sldIdLst>
   <p:sldSz cx="12192000" cy="6858000"/>
   <p:notesSz cx="6858000" cy="9144000"/>
@@ -447,7 +447,32 @@
           <a:lstStyle xmlns:a="http://schemas.openxmlformats.org/drawingml/2006/main"/>
           <a:p xmlns:a="http://schemas.openxmlformats.org/drawingml/2006/main">
             <a:r>
-              <a:t>來源、研究限制及完整網址見 m1-world/world-research.md。圖像出處見 references/README.md。</a:t>
+              <a:t>研究來源：https://journals.plos.org/plosone/article?id=10.1371/journal.pone.0182869</a:t>
+            </a:r>
+          </a:p>
+          <a:p xmlns:a="http://schemas.openxmlformats.org/drawingml/2006/main">
+            <a:r>
+              <a:t>https://www.nature.com/articles/s41598-019-41032-4</a:t>
+            </a:r>
+          </a:p>
+          <a:p xmlns:a="http://schemas.openxmlformats.org/drawingml/2006/main">
+            <a:r>
+              <a:t>https://acp.copernicus.org/articles/14/1485/2014/</a:t>
+            </a:r>
+          </a:p>
+          <a:p xmlns:a="http://schemas.openxmlformats.org/drawingml/2006/main">
+            <a:r>
+              <a:t>https://www.frontiersin.org/journals/microbiology/articles/10.3389/fmicb.2016.00772/full</a:t>
+            </a:r>
+          </a:p>
+          <a:p xmlns:a="http://schemas.openxmlformats.org/drawingml/2006/main">
+            <a:r>
+              <a:t>https://weather.metoffice.gov.uk/learn-about/weather/how-weather-works/water-cycle</a:t>
+            </a:r>
+          </a:p>
+          <a:p xmlns:a="http://schemas.openxmlformats.org/drawingml/2006/main">
+            <a:r>
+              <a:t>封面照片：NASA/JSC，ISS066-E-37532，北大西洋。</a:t>
             </a:r>
           </a:p>
         </p:txBody>
@@ -517,7 +542,32 @@
           <a:lstStyle xmlns:a="http://schemas.openxmlformats.org/drawingml/2006/main"/>
           <a:p xmlns:a="http://schemas.openxmlformats.org/drawingml/2006/main">
             <a:r>
-              <a:t>來源、研究限制及完整網址見 m1-world/world-research.md。圖像出處見 references/README.md。</a:t>
+              <a:t>研究來源：https://journals.plos.org/plosone/article?id=10.1371/journal.pone.0182869</a:t>
+            </a:r>
+          </a:p>
+          <a:p xmlns:a="http://schemas.openxmlformats.org/drawingml/2006/main">
+            <a:r>
+              <a:t>https://www.nature.com/articles/s41598-019-41032-4</a:t>
+            </a:r>
+          </a:p>
+          <a:p xmlns:a="http://schemas.openxmlformats.org/drawingml/2006/main">
+            <a:r>
+              <a:t>https://acp.copernicus.org/articles/14/1485/2014/</a:t>
+            </a:r>
+          </a:p>
+          <a:p xmlns:a="http://schemas.openxmlformats.org/drawingml/2006/main">
+            <a:r>
+              <a:t>https://www.frontiersin.org/journals/microbiology/articles/10.3389/fmicb.2016.00772/full</a:t>
+            </a:r>
+          </a:p>
+          <a:p xmlns:a="http://schemas.openxmlformats.org/drawingml/2006/main">
+            <a:r>
+              <a:t>https://weather.metoffice.gov.uk/learn-about/weather/how-weather-works/water-cycle</a:t>
+            </a:r>
+          </a:p>
+          <a:p xmlns:a="http://schemas.openxmlformats.org/drawingml/2006/main">
+            <a:r>
+              <a:t>封面照片：NASA/JSC，ISS066-E-37532，北大西洋。</a:t>
             </a:r>
           </a:p>
         </p:txBody>
@@ -587,7 +637,32 @@
           <a:lstStyle xmlns:a="http://schemas.openxmlformats.org/drawingml/2006/main"/>
           <a:p xmlns:a="http://schemas.openxmlformats.org/drawingml/2006/main">
             <a:r>
-              <a:t>來源、研究限制及完整網址見 m1-world/world-research.md。圖像出處見 references/README.md。</a:t>
+              <a:t>研究來源：https://journals.plos.org/plosone/article?id=10.1371/journal.pone.0182869</a:t>
+            </a:r>
+          </a:p>
+          <a:p xmlns:a="http://schemas.openxmlformats.org/drawingml/2006/main">
+            <a:r>
+              <a:t>https://www.nature.com/articles/s41598-019-41032-4</a:t>
+            </a:r>
+          </a:p>
+          <a:p xmlns:a="http://schemas.openxmlformats.org/drawingml/2006/main">
+            <a:r>
+              <a:t>https://acp.copernicus.org/articles/14/1485/2014/</a:t>
+            </a:r>
+          </a:p>
+          <a:p xmlns:a="http://schemas.openxmlformats.org/drawingml/2006/main">
+            <a:r>
+              <a:t>https://www.frontiersin.org/journals/microbiology/articles/10.3389/fmicb.2016.00772/full</a:t>
+            </a:r>
+          </a:p>
+          <a:p xmlns:a="http://schemas.openxmlformats.org/drawingml/2006/main">
+            <a:r>
+              <a:t>https://weather.metoffice.gov.uk/learn-about/weather/how-weather-works/water-cycle</a:t>
+            </a:r>
+          </a:p>
+          <a:p xmlns:a="http://schemas.openxmlformats.org/drawingml/2006/main">
+            <a:r>
+              <a:t>封面照片：NASA/JSC，ISS066-E-37532，北大西洋。</a:t>
             </a:r>
           </a:p>
         </p:txBody>
@@ -657,7 +732,32 @@
           <a:lstStyle xmlns:a="http://schemas.openxmlformats.org/drawingml/2006/main"/>
           <a:p xmlns:a="http://schemas.openxmlformats.org/drawingml/2006/main">
             <a:r>
-              <a:t>來源、研究限制及完整網址見 m1-world/world-research.md。圖像出處見 references/README.md。</a:t>
+              <a:t>研究來源：https://journals.plos.org/plosone/article?id=10.1371/journal.pone.0182869</a:t>
+            </a:r>
+          </a:p>
+          <a:p xmlns:a="http://schemas.openxmlformats.org/drawingml/2006/main">
+            <a:r>
+              <a:t>https://www.nature.com/articles/s41598-019-41032-4</a:t>
+            </a:r>
+          </a:p>
+          <a:p xmlns:a="http://schemas.openxmlformats.org/drawingml/2006/main">
+            <a:r>
+              <a:t>https://acp.copernicus.org/articles/14/1485/2014/</a:t>
+            </a:r>
+          </a:p>
+          <a:p xmlns:a="http://schemas.openxmlformats.org/drawingml/2006/main">
+            <a:r>
+              <a:t>https://www.frontiersin.org/journals/microbiology/articles/10.3389/fmicb.2016.00772/full</a:t>
+            </a:r>
+          </a:p>
+          <a:p xmlns:a="http://schemas.openxmlformats.org/drawingml/2006/main">
+            <a:r>
+              <a:t>https://weather.metoffice.gov.uk/learn-about/weather/how-weather-works/water-cycle</a:t>
+            </a:r>
+          </a:p>
+          <a:p xmlns:a="http://schemas.openxmlformats.org/drawingml/2006/main">
+            <a:r>
+              <a:t>封面照片：NASA/JSC，ISS066-E-37532，北大西洋。</a:t>
             </a:r>
           </a:p>
         </p:txBody>
@@ -727,7 +827,32 @@
           <a:lstStyle xmlns:a="http://schemas.openxmlformats.org/drawingml/2006/main"/>
           <a:p xmlns:a="http://schemas.openxmlformats.org/drawingml/2006/main">
             <a:r>
-              <a:t>來源、研究限制及完整網址見 m1-world/world-research.md。圖像出處見 references/README.md。</a:t>
+              <a:t>研究來源：https://journals.plos.org/plosone/article?id=10.1371/journal.pone.0182869</a:t>
+            </a:r>
+          </a:p>
+          <a:p xmlns:a="http://schemas.openxmlformats.org/drawingml/2006/main">
+            <a:r>
+              <a:t>https://www.nature.com/articles/s41598-019-41032-4</a:t>
+            </a:r>
+          </a:p>
+          <a:p xmlns:a="http://schemas.openxmlformats.org/drawingml/2006/main">
+            <a:r>
+              <a:t>https://acp.copernicus.org/articles/14/1485/2014/</a:t>
+            </a:r>
+          </a:p>
+          <a:p xmlns:a="http://schemas.openxmlformats.org/drawingml/2006/main">
+            <a:r>
+              <a:t>https://www.frontiersin.org/journals/microbiology/articles/10.3389/fmicb.2016.00772/full</a:t>
+            </a:r>
+          </a:p>
+          <a:p xmlns:a="http://schemas.openxmlformats.org/drawingml/2006/main">
+            <a:r>
+              <a:t>https://weather.metoffice.gov.uk/learn-about/weather/how-weather-works/water-cycle</a:t>
+            </a:r>
+          </a:p>
+          <a:p xmlns:a="http://schemas.openxmlformats.org/drawingml/2006/main">
+            <a:r>
+              <a:t>封面照片：NASA/JSC，ISS066-E-37532，北大西洋。</a:t>
             </a:r>
           </a:p>
         </p:txBody>
@@ -797,7 +922,32 @@
           <a:lstStyle xmlns:a="http://schemas.openxmlformats.org/drawingml/2006/main"/>
           <a:p xmlns:a="http://schemas.openxmlformats.org/drawingml/2006/main">
             <a:r>
-              <a:t>來源、研究限制及完整網址見 m1-world/world-research.md。圖像出處見 references/README.md。</a:t>
+              <a:t>研究來源：https://journals.plos.org/plosone/article?id=10.1371/journal.pone.0182869</a:t>
+            </a:r>
+          </a:p>
+          <a:p xmlns:a="http://schemas.openxmlformats.org/drawingml/2006/main">
+            <a:r>
+              <a:t>https://www.nature.com/articles/s41598-019-41032-4</a:t>
+            </a:r>
+          </a:p>
+          <a:p xmlns:a="http://schemas.openxmlformats.org/drawingml/2006/main">
+            <a:r>
+              <a:t>https://acp.copernicus.org/articles/14/1485/2014/</a:t>
+            </a:r>
+          </a:p>
+          <a:p xmlns:a="http://schemas.openxmlformats.org/drawingml/2006/main">
+            <a:r>
+              <a:t>https://www.frontiersin.org/journals/microbiology/articles/10.3389/fmicb.2016.00772/full</a:t>
+            </a:r>
+          </a:p>
+          <a:p xmlns:a="http://schemas.openxmlformats.org/drawingml/2006/main">
+            <a:r>
+              <a:t>https://weather.metoffice.gov.uk/learn-about/weather/how-weather-works/water-cycle</a:t>
+            </a:r>
+          </a:p>
+          <a:p xmlns:a="http://schemas.openxmlformats.org/drawingml/2006/main">
+            <a:r>
+              <a:t>封面照片：NASA/JSC，ISS066-E-37532，北大西洋。</a:t>
             </a:r>
           </a:p>
         </p:txBody>
@@ -865,7 +1015,7 @@
   </p:cSld>
   <p:clrMap bg1="lt1" tx1="dk1" bg2="lt2" tx2="dk2" accent1="accent1" accent2="accent2" accent3="accent3" accent4="accent4" accent5="accent5" accent6="accent6" hlink="hlink" folHlink="folHlink"/>
   <p:sldLayoutIdLst>
-    <p:sldLayoutId xmlns:r="http://schemas.openxmlformats.org/officeDocument/2006/relationships" id="2147483649" r:id="R9182d7c2abb54a69"/>
+    <p:sldLayoutId xmlns:r="http://schemas.openxmlformats.org/officeDocument/2006/relationships" id="2147483649" r:id="R0ade909f90274cb6"/>
   </p:sldLayoutIdLst>
   <p:txStyles>
     <p:titleStyle>
@@ -1413,14 +1563,14 @@
       </p:grpSpPr>
       <p:pic>
         <p:nvPicPr>
-          <p:cNvPr id="7" name=""/>
+          <p:cNvPr id="8" name=""/>
           <p:cNvPicPr>
             <a:picLocks xmlns:a="http://schemas.openxmlformats.org/drawingml/2006/main" noChangeAspect="1"/>
           </p:cNvPicPr>
           <p:nvPr/>
         </p:nvPicPr>
         <p:blipFill>
-          <a:blip xmlns:r="http://schemas.openxmlformats.org/officeDocument/2006/relationships" xmlns:a="http://schemas.openxmlformats.org/drawingml/2006/main" r:embed="R7cbf5a5656504c31"/>
+          <a:blip xmlns:r="http://schemas.openxmlformats.org/officeDocument/2006/relationships" xmlns:a="http://schemas.openxmlformats.org/drawingml/2006/main" r:embed="R73954c0ab89e431d"/>
           <a:srcRect xmlns:a="http://schemas.openxmlformats.org/drawingml/2006/main" l="23904" t="0" r="23904" b="0"/>
           <a:stretch xmlns:a="http://schemas.openxmlformats.org/drawingml/2006/main">
             <a:fillRect l="0" t="0" r="0" b="0"/>
@@ -1470,6 +1620,7 @@
           <a:lstStyle xmlns:a="http://schemas.openxmlformats.org/drawingml/2006/main"/>
           <a:p xmlns:a="http://schemas.openxmlformats.org/drawingml/2006/main">
             <a:pPr>
+              <a:buNone/>
               <a:defRPr sz="1425" b="0">
                 <a:solidFill>
                   <a:srgbClr val="ADC1D5"/>
@@ -1527,6 +1678,7 @@
           <a:lstStyle xmlns:a="http://schemas.openxmlformats.org/drawingml/2006/main"/>
           <a:p xmlns:a="http://schemas.openxmlformats.org/drawingml/2006/main">
             <a:pPr>
+              <a:buNone/>
               <a:defRPr sz="4950" b="1">
                 <a:solidFill>
                   <a:srgbClr val="E9EDF1"/>
@@ -1550,6 +1702,7 @@
           </a:p>
           <a:p xmlns:a="http://schemas.openxmlformats.org/drawingml/2006/main">
             <a:pPr>
+              <a:buNone/>
               <a:defRPr sz="4950" b="1">
                 <a:solidFill>
                   <a:srgbClr val="E9EDF1"/>
@@ -1607,6 +1760,7 @@
           <a:lstStyle xmlns:a="http://schemas.openxmlformats.org/drawingml/2006/main"/>
           <a:p xmlns:a="http://schemas.openxmlformats.org/drawingml/2006/main">
             <a:pPr>
+              <a:buNone/>
               <a:defRPr sz="2175" b="0">
                 <a:solidFill>
                   <a:srgbClr val="E9EDF1"/>
@@ -1630,6 +1784,7 @@
           </a:p>
           <a:p xmlns:a="http://schemas.openxmlformats.org/drawingml/2006/main">
             <a:pPr>
+              <a:buNone/>
               <a:defRPr sz="2175" b="0">
                 <a:solidFill>
                   <a:srgbClr val="E9EDF1"/>
@@ -1687,6 +1842,7 @@
           <a:lstStyle xmlns:a="http://schemas.openxmlformats.org/drawingml/2006/main"/>
           <a:p xmlns:a="http://schemas.openxmlformats.org/drawingml/2006/main">
             <a:pPr>
+              <a:buNone/>
               <a:defRPr sz="2025" b="0">
                 <a:solidFill>
                   <a:srgbClr val="B9C7D8"/>
@@ -1705,11 +1861,12 @@
                 <a:ea typeface="Heiti TC"/>
                 <a:cs typeface="Heiti TC"/>
               </a:rPr>
-              <a:t>最大的生存挑戰：</a:t>
-            </a:r>
-          </a:p>
-          <a:p xmlns:a="http://schemas.openxmlformats.org/drawingml/2006/main">
-            <a:pPr>
+              <a:t>花園隨著雲移動，</a:t>
+            </a:r>
+          </a:p>
+          <a:p xmlns:a="http://schemas.openxmlformats.org/drawingml/2006/main">
+            <a:pPr>
+              <a:buNone/>
               <a:defRPr sz="2025" b="0">
                 <a:solidFill>
                   <a:srgbClr val="B9C7D8"/>
@@ -1728,11 +1885,12 @@
                 <a:ea typeface="Heiti TC"/>
                 <a:cs typeface="Heiti TC"/>
               </a:rPr>
-              <a:t>棲地會隨雲滴蒸發</a:t>
-            </a:r>
-          </a:p>
-          <a:p xmlns:a="http://schemas.openxmlformats.org/drawingml/2006/main">
-            <a:pPr>
+              <a:t>也隨著雨散開。</a:t>
+            </a:r>
+          </a:p>
+          <a:p xmlns:a="http://schemas.openxmlformats.org/drawingml/2006/main">
+            <a:pPr>
+              <a:buNone/>
               <a:defRPr sz="2025" b="0">
                 <a:solidFill>
                   <a:srgbClr val="B9C7D8"/>
@@ -1751,7 +1909,7 @@
                 <a:ea typeface="Heiti TC"/>
                 <a:cs typeface="Heiti TC"/>
               </a:rPr>
-              <a:t>或降雨而消失。</a:t>
+              <a:t>生命得適應短暫的棲地。</a:t>
             </a:r>
           </a:p>
         </p:txBody>
@@ -1790,6 +1948,7 @@
           <a:lstStyle xmlns:a="http://schemas.openxmlformats.org/drawingml/2006/main"/>
           <a:p xmlns:a="http://schemas.openxmlformats.org/drawingml/2006/main">
             <a:pPr>
+              <a:buNone/>
               <a:defRPr sz="1050" b="0">
                 <a:solidFill>
                   <a:srgbClr val="98A9BA"/>
@@ -1808,7 +1967,7 @@
                 <a:ea typeface="Heiti TC"/>
                 <a:cs typeface="Heiti TC"/>
               </a:rPr>
-              <a:t>雲景參考：NASA/JSC，北大西洋，非多姆山</a:t>
+              <a:t>雲景參考：NASA/JSC，北大西洋</a:t>
             </a:r>
           </a:p>
         </p:txBody>
@@ -1876,6 +2035,7 @@
           <a:lstStyle xmlns:a="http://schemas.openxmlformats.org/drawingml/2006/main"/>
           <a:p xmlns:a="http://schemas.openxmlformats.org/drawingml/2006/main">
             <a:pPr>
+              <a:buNone/>
               <a:defRPr sz="1350" b="0">
                 <a:solidFill>
                   <a:srgbClr val="818F9F"/>
@@ -1933,6 +2093,7 @@
           <a:lstStyle xmlns:a="http://schemas.openxmlformats.org/drawingml/2006/main"/>
           <a:p xmlns:a="http://schemas.openxmlformats.org/drawingml/2006/main">
             <a:pPr>
+              <a:buNone/>
               <a:defRPr sz="3900" b="0">
                 <a:solidFill>
                   <a:srgbClr val="25303B"/>
@@ -1990,6 +2151,7 @@
           <a:lstStyle xmlns:a="http://schemas.openxmlformats.org/drawingml/2006/main"/>
           <a:p xmlns:a="http://schemas.openxmlformats.org/drawingml/2006/main">
             <a:pPr>
+              <a:buNone/>
               <a:defRPr sz="1275" b="0">
                 <a:solidFill>
                   <a:srgbClr val="818F9F"/>
@@ -2047,6 +2209,7 @@
           <a:lstStyle xmlns:a="http://schemas.openxmlformats.org/drawingml/2006/main"/>
           <a:p xmlns:a="http://schemas.openxmlformats.org/drawingml/2006/main">
             <a:pPr>
+              <a:buNone/>
               <a:defRPr sz="1500" b="0">
                 <a:solidFill>
                   <a:srgbClr val="818F9F"/>
@@ -2104,6 +2267,7 @@
           <a:lstStyle xmlns:a="http://schemas.openxmlformats.org/drawingml/2006/main"/>
           <a:p xmlns:a="http://schemas.openxmlformats.org/drawingml/2006/main">
             <a:pPr>
+              <a:buNone/>
               <a:defRPr sz="2400" b="0">
                 <a:solidFill>
                   <a:srgbClr val="25303B"/>
@@ -2127,6 +2291,7 @@
           </a:p>
           <a:p xmlns:a="http://schemas.openxmlformats.org/drawingml/2006/main">
             <a:pPr>
+              <a:buNone/>
               <a:defRPr sz="2400" b="0">
                 <a:solidFill>
                   <a:srgbClr val="25303B"/>
@@ -2184,6 +2349,7 @@
           <a:lstStyle xmlns:a="http://schemas.openxmlformats.org/drawingml/2006/main"/>
           <a:p xmlns:a="http://schemas.openxmlformats.org/drawingml/2006/main">
             <a:pPr>
+              <a:buNone/>
               <a:defRPr sz="1800" b="0">
                 <a:solidFill>
                   <a:srgbClr val="657282"/>
@@ -2241,6 +2407,7 @@
           <a:lstStyle xmlns:a="http://schemas.openxmlformats.org/drawingml/2006/main"/>
           <a:p xmlns:a="http://schemas.openxmlformats.org/drawingml/2006/main">
             <a:pPr>
+              <a:buNone/>
               <a:defRPr sz="2100" b="0">
                 <a:solidFill>
                   <a:srgbClr val="55687E"/>
@@ -2264,6 +2431,7 @@
           </a:p>
           <a:p xmlns:a="http://schemas.openxmlformats.org/drawingml/2006/main">
             <a:pPr>
+              <a:buNone/>
               <a:defRPr sz="2100" b="0">
                 <a:solidFill>
                   <a:srgbClr val="55687E"/>
@@ -2321,6 +2489,7 @@
           <a:lstStyle xmlns:a="http://schemas.openxmlformats.org/drawingml/2006/main"/>
           <a:p xmlns:a="http://schemas.openxmlformats.org/drawingml/2006/main">
             <a:pPr>
+              <a:buNone/>
               <a:defRPr sz="2100" b="1">
                 <a:solidFill>
                   <a:srgbClr val="25303B"/>
@@ -2339,7 +2508,7 @@
                 <a:ea typeface="Heiti TC"/>
                 <a:cs typeface="Heiti TC"/>
               </a:rPr>
-              <a:t>時間｜500 年</a:t>
+              <a:t>人類消失後 500 年</a:t>
             </a:r>
           </a:p>
         </p:txBody>
@@ -2378,6 +2547,7 @@
           <a:lstStyle xmlns:a="http://schemas.openxmlformats.org/drawingml/2006/main"/>
           <a:p xmlns:a="http://schemas.openxmlformats.org/drawingml/2006/main">
             <a:pPr>
+              <a:buNone/>
               <a:defRPr sz="1650" b="0">
                 <a:solidFill>
                   <a:srgbClr val="657282"/>
@@ -2396,7 +2566,7 @@
                 <a:ea typeface="Heiti TC"/>
                 <a:cs typeface="Heiti TC"/>
               </a:rPr>
-              <a:t>敘事尺度，並非演化或氣候預測。</a:t>
+              <a:t>我把故事放在人類離開五百年之後。</a:t>
             </a:r>
           </a:p>
         </p:txBody>
@@ -2435,6 +2605,7 @@
           <a:lstStyle xmlns:a="http://schemas.openxmlformats.org/drawingml/2006/main"/>
           <a:p xmlns:a="http://schemas.openxmlformats.org/drawingml/2006/main">
             <a:pPr>
+              <a:buNone/>
               <a:defRPr sz="2100" b="1">
                 <a:solidFill>
                   <a:srgbClr val="25303B"/>
@@ -2453,7 +2624,7 @@
                 <a:ea typeface="Heiti TC"/>
                 <a:cs typeface="Heiti TC"/>
               </a:rPr>
-              <a:t>棲地｜雲霧與山坡之間</a:t>
+              <a:t>多姆山的雲霧與山坡</a:t>
             </a:r>
           </a:p>
         </p:txBody>
@@ -2492,6 +2663,7 @@
           <a:lstStyle xmlns:a="http://schemas.openxmlformats.org/drawingml/2006/main"/>
           <a:p xmlns:a="http://schemas.openxmlformats.org/drawingml/2006/main">
             <a:pPr>
+              <a:buNone/>
               <a:defRPr sz="1650" b="0">
                 <a:solidFill>
                   <a:srgbClr val="657282"/>
@@ -2510,7 +2682,7 @@
                 <a:ea typeface="Heiti TC"/>
                 <a:cs typeface="Heiti TC"/>
               </a:rPr>
-              <a:t>現有研究取樣站海拔 1465 m。[1][3]</a:t>
+              <a:t>這裡的雲水研究站海拔 1465 公尺。[1][3]</a:t>
             </a:r>
           </a:p>
         </p:txBody>
@@ -2549,6 +2721,7 @@
           <a:lstStyle xmlns:a="http://schemas.openxmlformats.org/drawingml/2006/main"/>
           <a:p xmlns:a="http://schemas.openxmlformats.org/drawingml/2006/main">
             <a:pPr>
+              <a:buNone/>
               <a:defRPr sz="2100" b="1">
                 <a:solidFill>
                   <a:srgbClr val="25303B"/>
@@ -2567,7 +2740,7 @@
                 <a:ea typeface="Heiti TC"/>
                 <a:cs typeface="Heiti TC"/>
               </a:rPr>
-              <a:t>場景｜涼濕、會改變的雲水</a:t>
+              <a:t>涼濕、光線忽明忽暗</a:t>
             </a:r>
           </a:p>
         </p:txBody>
@@ -2606,7 +2779,8 @@
           <a:lstStyle xmlns:a="http://schemas.openxmlformats.org/drawingml/2006/main"/>
           <a:p xmlns:a="http://schemas.openxmlformats.org/drawingml/2006/main">
             <a:pPr>
-              <a:defRPr sz="1650" b="0">
+              <a:buNone/>
+              <a:defRPr sz="1575" b="0">
                 <a:solidFill>
                   <a:srgbClr val="657282"/>
                 </a:solidFill>
@@ -2616,7 +2790,7 @@
               </a:defRPr>
             </a:pPr>
             <a:r>
-              <a:rPr sz="1650" b="0">
+              <a:rPr sz="1575" b="0">
                 <a:solidFill>
                   <a:srgbClr val="657282"/>
                 </a:solidFill>
@@ -2624,7 +2798,7 @@
                 <a:ea typeface="Heiti TC"/>
                 <a:cs typeface="Heiti TC"/>
               </a:rPr>
-              <a:t>展示設定 0–10°C；水與養分不穩定。</a:t>
+              <a:t>我想讓花園出現在接近冰點到 10°C 的雲霧裡。</a:t>
             </a:r>
           </a:p>
         </p:txBody>
@@ -2663,6 +2837,7 @@
           <a:lstStyle xmlns:a="http://schemas.openxmlformats.org/drawingml/2006/main"/>
           <a:p xmlns:a="http://schemas.openxmlformats.org/drawingml/2006/main">
             <a:pPr>
+              <a:buNone/>
               <a:defRPr sz="2100" b="1">
                 <a:solidFill>
                   <a:srgbClr val="25303B"/>
@@ -2681,7 +2856,7 @@
                 <a:ea typeface="Heiti TC"/>
                 <a:cs typeface="Heiti TC"/>
               </a:rPr>
-              <a:t>遺物｜地面的玻璃與陶瓷碎片</a:t>
+              <a:t>地面留下人類的痕跡</a:t>
             </a:r>
           </a:p>
         </p:txBody>
@@ -2720,7 +2895,8 @@
           <a:lstStyle xmlns:a="http://schemas.openxmlformats.org/drawingml/2006/main"/>
           <a:p xmlns:a="http://schemas.openxmlformats.org/drawingml/2006/main">
             <a:pPr>
-              <a:defRPr sz="1650" b="0">
+              <a:buNone/>
+              <a:defRPr sz="1575" b="0">
                 <a:solidFill>
                   <a:srgbClr val="657282"/>
                 </a:solidFill>
@@ -2730,7 +2906,7 @@
               </a:defRPr>
             </a:pPr>
             <a:r>
-              <a:rPr sz="1650" b="0">
+              <a:rPr sz="1575" b="0">
                 <a:solidFill>
                   <a:srgbClr val="657282"/>
                 </a:solidFill>
@@ -2738,7 +2914,7 @@
                 <a:ea typeface="Heiti TC"/>
                 <a:cs typeface="Heiti TC"/>
               </a:rPr>
-              <a:t>創作設定；不假定機器仍能運作。</a:t>
+              <a:t>玻璃、陶瓷碎片和舊設施成為場景的一部分。</a:t>
             </a:r>
           </a:p>
         </p:txBody>
@@ -2806,6 +2982,7 @@
           <a:lstStyle xmlns:a="http://schemas.openxmlformats.org/drawingml/2006/main"/>
           <a:p xmlns:a="http://schemas.openxmlformats.org/drawingml/2006/main">
             <a:pPr>
+              <a:buNone/>
               <a:defRPr sz="1350" b="0">
                 <a:solidFill>
                   <a:srgbClr val="818F9F"/>
@@ -2824,7 +3001,7 @@
                 <a:ea typeface="Heiti TC"/>
                 <a:cs typeface="Heiti TC"/>
               </a:rPr>
-              <a:t>M1 / 後未來動物園     查證事實 01 / 02</a:t>
+              <a:t>M1 / 後未來動物園     雲中的生命</a:t>
             </a:r>
           </a:p>
         </p:txBody>
@@ -2863,6 +3040,7 @@
           <a:lstStyle xmlns:a="http://schemas.openxmlformats.org/drawingml/2006/main"/>
           <a:p xmlns:a="http://schemas.openxmlformats.org/drawingml/2006/main">
             <a:pPr>
+              <a:buNone/>
               <a:defRPr sz="3900" b="0">
                 <a:solidFill>
                   <a:srgbClr val="E9EDF1"/>
@@ -2881,7 +3059,7 @@
                 <a:ea typeface="Heiti TC"/>
                 <a:cs typeface="Heiti TC"/>
               </a:rPr>
-              <a:t>雲不是空的，卻也不是安穩的家</a:t>
+              <a:t>雲裡也有微生物</a:t>
             </a:r>
           </a:p>
         </p:txBody>
@@ -2920,6 +3098,7 @@
           <a:lstStyle xmlns:a="http://schemas.openxmlformats.org/drawingml/2006/main"/>
           <a:p xmlns:a="http://schemas.openxmlformats.org/drawingml/2006/main">
             <a:pPr>
+              <a:buNone/>
               <a:defRPr sz="1275" b="0">
                 <a:solidFill>
                   <a:srgbClr val="818F9F"/>
@@ -2977,6 +3156,7 @@
           <a:lstStyle xmlns:a="http://schemas.openxmlformats.org/drawingml/2006/main"/>
           <a:p xmlns:a="http://schemas.openxmlformats.org/drawingml/2006/main">
             <a:pPr>
+              <a:buNone/>
               <a:defRPr sz="1500" b="0">
                 <a:solidFill>
                   <a:srgbClr val="818F9F"/>
@@ -3034,6 +3214,7 @@
           <a:lstStyle xmlns:a="http://schemas.openxmlformats.org/drawingml/2006/main"/>
           <a:p xmlns:a="http://schemas.openxmlformats.org/drawingml/2006/main">
             <a:pPr>
+              <a:buNone/>
               <a:defRPr sz="2400" b="1">
                 <a:solidFill>
                   <a:srgbClr val="BED3E8"/>
@@ -3052,7 +3233,7 @@
                 <a:ea typeface="Heiti TC"/>
                 <a:cs typeface="Heiti TC"/>
               </a:rPr>
-              <a:t>01  雲水裡有活動跡象</a:t>
+              <a:t>雲水中的生命活動</a:t>
             </a:r>
           </a:p>
         </p:txBody>
@@ -3091,6 +3272,7 @@
           <a:lstStyle xmlns:a="http://schemas.openxmlformats.org/drawingml/2006/main"/>
           <a:p xmlns:a="http://schemas.openxmlformats.org/drawingml/2006/main">
             <a:pPr>
+              <a:buNone/>
               <a:defRPr sz="2025" b="0">
                 <a:solidFill>
                   <a:srgbClr val="E9EDF1"/>
@@ -3109,11 +3291,12 @@
                 <a:ea typeface="Heiti TC"/>
                 <a:cs typeface="Heiti TC"/>
               </a:rPr>
-              <a:t>多姆山雲水中的微生物，</a:t>
-            </a:r>
-          </a:p>
-          <a:p xmlns:a="http://schemas.openxmlformats.org/drawingml/2006/main">
-            <a:pPr>
+              <a:t>研究在多姆山的雲水裡，</a:t>
+            </a:r>
+          </a:p>
+          <a:p xmlns:a="http://schemas.openxmlformats.org/drawingml/2006/main">
+            <a:pPr>
+              <a:buNone/>
               <a:defRPr sz="2025" b="0">
                 <a:solidFill>
                   <a:srgbClr val="E9EDF1"/>
@@ -3132,7 +3315,7 @@
                 <a:ea typeface="Heiti TC"/>
                 <a:cs typeface="Heiti TC"/>
               </a:rPr>
-              <a:t>呈現支持活動的分子證據。</a:t>
+              <a:t>找到微生物活動的跡象。</a:t>
             </a:r>
           </a:p>
           <a:p xmlns:a="http://schemas.openxmlformats.org/drawingml/2006/main">
@@ -3142,6 +3325,7 @@
           </a:p>
           <a:p xmlns:a="http://schemas.openxmlformats.org/drawingml/2006/main">
             <a:pPr>
+              <a:buNone/>
               <a:defRPr sz="2025" b="0">
                 <a:solidFill>
                   <a:srgbClr val="E9EDF1"/>
@@ -3160,7 +3344,7 @@
                 <a:ea typeface="Heiti TC"/>
                 <a:cs typeface="Heiti TC"/>
               </a:rPr>
-              <a:t>有 RNA ≠ 已證明持續繁殖</a:t>
+              <a:t>這讓雲成為生命可能停留的地方。</a:t>
             </a:r>
           </a:p>
         </p:txBody>
@@ -3199,6 +3383,7 @@
           <a:lstStyle xmlns:a="http://schemas.openxmlformats.org/drawingml/2006/main"/>
           <a:p xmlns:a="http://schemas.openxmlformats.org/drawingml/2006/main">
             <a:pPr>
+              <a:buNone/>
               <a:defRPr sz="1425" b="0">
                 <a:solidFill>
                   <a:srgbClr val="95A6B9"/>
@@ -3222,6 +3407,7 @@
           </a:p>
           <a:p xmlns:a="http://schemas.openxmlformats.org/drawingml/2006/main">
             <a:pPr>
+              <a:buNone/>
               <a:defRPr sz="1425" b="0">
                 <a:solidFill>
                   <a:srgbClr val="95A6B9"/>
@@ -3240,7 +3426,7 @@
                 <a:ea typeface="Heiti TC"/>
                 <a:cs typeface="Heiti TC"/>
               </a:rPr>
-              <a:t>獨立對照：Klein et al., 2016 [4]</a:t>
+              <a:t>Klein et al., 2016 [4]</a:t>
             </a:r>
           </a:p>
         </p:txBody>
@@ -3279,6 +3465,7 @@
           <a:lstStyle xmlns:a="http://schemas.openxmlformats.org/drawingml/2006/main"/>
           <a:p xmlns:a="http://schemas.openxmlformats.org/drawingml/2006/main">
             <a:pPr>
+              <a:buNone/>
               <a:defRPr sz="2400" b="1">
                 <a:solidFill>
                   <a:srgbClr val="BED3E8"/>
@@ -3297,7 +3484,7 @@
                 <a:ea typeface="Heiti TC"/>
                 <a:cs typeface="Heiti TC"/>
               </a:rPr>
-              <a:t>02  活著需要防護成本</a:t>
+              <a:t>低溫與乾濕變化</a:t>
             </a:r>
           </a:p>
         </p:txBody>
@@ -3336,6 +3523,7 @@
           <a:lstStyle xmlns:a="http://schemas.openxmlformats.org/drawingml/2006/main"/>
           <a:p xmlns:a="http://schemas.openxmlformats.org/drawingml/2006/main">
             <a:pPr>
+              <a:buNone/>
               <a:defRPr sz="2025" b="0">
                 <a:solidFill>
                   <a:srgbClr val="E9EDF1"/>
@@ -3354,11 +3542,12 @@
                 <a:ea typeface="Heiti TC"/>
                 <a:cs typeface="Heiti TC"/>
               </a:rPr>
-              <a:t>研究找到抗氧化、耐冷與</a:t>
-            </a:r>
-          </a:p>
-          <a:p xmlns:a="http://schemas.openxmlformats.org/drawingml/2006/main">
-            <a:pPr>
+              <a:t>研究發現微生物具有抗氧化、</a:t>
+            </a:r>
+          </a:p>
+          <a:p xmlns:a="http://schemas.openxmlformats.org/drawingml/2006/main">
+            <a:pPr>
+              <a:buNone/>
               <a:defRPr sz="2025" b="0">
                 <a:solidFill>
                   <a:srgbClr val="E9EDF1"/>
@@ -3377,7 +3566,7 @@
                 <a:ea typeface="Heiti TC"/>
                 <a:cs typeface="Heiti TC"/>
               </a:rPr>
-              <a:t>滲透條件調節的功能。</a:t>
+              <a:t>耐冷與調節滲透條件的功能。</a:t>
             </a:r>
           </a:p>
           <a:p xmlns:a="http://schemas.openxmlformats.org/drawingml/2006/main">
@@ -3387,6 +3576,7 @@
           </a:p>
           <a:p xmlns:a="http://schemas.openxmlformats.org/drawingml/2006/main">
             <a:pPr>
+              <a:buNone/>
               <a:defRPr sz="2025" b="0">
                 <a:solidFill>
                   <a:srgbClr val="E9EDF1"/>
@@ -3405,7 +3595,7 @@
                 <a:ea typeface="Heiti TC"/>
                 <a:cs typeface="Heiti TC"/>
               </a:rPr>
-              <a:t>基因表現 ≠ 實際代謝速率</a:t>
+              <a:t>雲中的生活也需要抵抗環境壓力。</a:t>
             </a:r>
           </a:p>
         </p:txBody>
@@ -3444,6 +3634,7 @@
           <a:lstStyle xmlns:a="http://schemas.openxmlformats.org/drawingml/2006/main"/>
           <a:p xmlns:a="http://schemas.openxmlformats.org/drawingml/2006/main">
             <a:pPr>
+              <a:buNone/>
               <a:defRPr sz="1425" b="0">
                 <a:solidFill>
                   <a:srgbClr val="95A6B9"/>
@@ -3463,29 +3654,6 @@
                 <a:cs typeface="Heiti TC"/>
               </a:rPr>
               <a:t>Amato et al., 2019 [2]</a:t>
-            </a:r>
-          </a:p>
-          <a:p xmlns:a="http://schemas.openxmlformats.org/drawingml/2006/main">
-            <a:pPr>
-              <a:defRPr sz="1425" b="0">
-                <a:solidFill>
-                  <a:srgbClr val="95A6B9"/>
-                </a:solidFill>
-                <a:latin typeface="Heiti TC"/>
-                <a:ea typeface="Heiti TC"/>
-                <a:cs typeface="Heiti TC"/>
-              </a:defRPr>
-            </a:pPr>
-            <a:r>
-              <a:rPr sz="1425" b="0">
-                <a:solidFill>
-                  <a:srgbClr val="95A6B9"/>
-                </a:solidFill>
-                <a:latin typeface="Heiti TC"/>
-                <a:ea typeface="Heiti TC"/>
-                <a:cs typeface="Heiti TC"/>
-              </a:rPr>
-              <a:t>夜間樣本；不是大型漂浮生命的證據。</a:t>
             </a:r>
           </a:p>
         </p:txBody>
@@ -3553,6 +3721,7 @@
           <a:lstStyle xmlns:a="http://schemas.openxmlformats.org/drawingml/2006/main"/>
           <a:p xmlns:a="http://schemas.openxmlformats.org/drawingml/2006/main">
             <a:pPr>
+              <a:buNone/>
               <a:defRPr sz="1350" b="0">
                 <a:solidFill>
                   <a:srgbClr val="818F9F"/>
@@ -3571,7 +3740,7 @@
                 <a:ea typeface="Heiti TC"/>
                 <a:cs typeface="Heiti TC"/>
               </a:rPr>
-              <a:t>M1 / 後未來動物園     查證事實 03 / 物理限制</a:t>
+              <a:t>M1 / 後未來動物園     水與環境</a:t>
             </a:r>
           </a:p>
         </p:txBody>
@@ -3610,6 +3779,7 @@
           <a:lstStyle xmlns:a="http://schemas.openxmlformats.org/drawingml/2006/main"/>
           <a:p xmlns:a="http://schemas.openxmlformats.org/drawingml/2006/main">
             <a:pPr>
+              <a:buNone/>
               <a:defRPr sz="3900" b="0">
                 <a:solidFill>
                   <a:srgbClr val="25303B"/>
@@ -3628,7 +3798,7 @@
                 <a:ea typeface="Heiti TC"/>
                 <a:cs typeface="Heiti TC"/>
               </a:rPr>
-              <a:t>棲地會變質，也會落下</a:t>
+              <a:t>花園會隨著雨改變</a:t>
             </a:r>
           </a:p>
         </p:txBody>
@@ -3667,6 +3837,7 @@
           <a:lstStyle xmlns:a="http://schemas.openxmlformats.org/drawingml/2006/main"/>
           <a:p xmlns:a="http://schemas.openxmlformats.org/drawingml/2006/main">
             <a:pPr>
+              <a:buNone/>
               <a:defRPr sz="1275" b="0">
                 <a:solidFill>
                   <a:srgbClr val="818F9F"/>
@@ -3724,6 +3895,7 @@
           <a:lstStyle xmlns:a="http://schemas.openxmlformats.org/drawingml/2006/main"/>
           <a:p xmlns:a="http://schemas.openxmlformats.org/drawingml/2006/main">
             <a:pPr>
+              <a:buNone/>
               <a:defRPr sz="1500" b="0">
                 <a:solidFill>
                   <a:srgbClr val="818F9F"/>
@@ -3781,6 +3953,7 @@
           <a:lstStyle xmlns:a="http://schemas.openxmlformats.org/drawingml/2006/main"/>
           <a:p xmlns:a="http://schemas.openxmlformats.org/drawingml/2006/main">
             <a:pPr>
+              <a:buNone/>
               <a:defRPr sz="2325" b="1">
                 <a:solidFill>
                   <a:srgbClr val="25303B"/>
@@ -3799,7 +3972,7 @@
                 <a:ea typeface="Heiti TC"/>
                 <a:cs typeface="Heiti TC"/>
               </a:rPr>
-              <a:t>03  每一片雲，條件都不同</a:t>
+              <a:t>雲水的成分會改變</a:t>
             </a:r>
           </a:p>
         </p:txBody>
@@ -3838,6 +4011,7 @@
           <a:lstStyle xmlns:a="http://schemas.openxmlformats.org/drawingml/2006/main"/>
           <a:p xmlns:a="http://schemas.openxmlformats.org/drawingml/2006/main">
             <a:pPr>
+              <a:buNone/>
               <a:defRPr sz="1875" b="0">
                 <a:solidFill>
                   <a:srgbClr val="3D4F61"/>
@@ -3856,11 +4030,12 @@
                 <a:ea typeface="Heiti TC"/>
                 <a:cs typeface="Heiti TC"/>
               </a:rPr>
-              <a:t>73 次雲事件、199 個樣本</a:t>
-            </a:r>
-          </a:p>
-          <a:p xmlns:a="http://schemas.openxmlformats.org/drawingml/2006/main">
-            <a:pPr>
+              <a:t>多姆山十年的雲水研究顯示，</a:t>
+            </a:r>
+          </a:p>
+          <a:p xmlns:a="http://schemas.openxmlformats.org/drawingml/2006/main">
+            <a:pPr>
+              <a:buNone/>
               <a:defRPr sz="1875" b="0">
                 <a:solidFill>
                   <a:srgbClr val="3D4F61"/>
@@ -3879,11 +4054,12 @@
                 <a:ea typeface="Heiti TC"/>
                 <a:cs typeface="Heiti TC"/>
               </a:rPr>
-              <a:t>氣團來源不同，酸鹼與離子也不同。</a:t>
-            </a:r>
-          </a:p>
-          <a:p xmlns:a="http://schemas.openxmlformats.org/drawingml/2006/main">
-            <a:pPr>
+              <a:t>不同氣團帶來的雲，</a:t>
+            </a:r>
+          </a:p>
+          <a:p xmlns:a="http://schemas.openxmlformats.org/drawingml/2006/main">
+            <a:pPr>
+              <a:buNone/>
               <a:defRPr sz="1875" b="0">
                 <a:solidFill>
                   <a:srgbClr val="3D4F61"/>
@@ -3902,7 +4078,7 @@
                 <a:ea typeface="Heiti TC"/>
                 <a:cs typeface="Heiti TC"/>
               </a:rPr>
-              <a:t>不能將現代污染數值搬到無人未來。</a:t>
+              <a:t>酸鹼與離子成分也不一樣。</a:t>
             </a:r>
           </a:p>
         </p:txBody>
@@ -3941,6 +4117,7 @@
           <a:lstStyle xmlns:a="http://schemas.openxmlformats.org/drawingml/2006/main"/>
           <a:p xmlns:a="http://schemas.openxmlformats.org/drawingml/2006/main">
             <a:pPr>
+              <a:buNone/>
               <a:defRPr sz="1425" b="0">
                 <a:solidFill>
                   <a:srgbClr val="657282"/>
@@ -3964,6 +4141,7 @@
           </a:p>
           <a:p xmlns:a="http://schemas.openxmlformats.org/drawingml/2006/main">
             <a:pPr>
+              <a:buNone/>
               <a:defRPr sz="1425" b="0">
                 <a:solidFill>
                   <a:srgbClr val="657282"/>
@@ -4021,6 +4199,7 @@
           <a:lstStyle xmlns:a="http://schemas.openxmlformats.org/drawingml/2006/main"/>
           <a:p xmlns:a="http://schemas.openxmlformats.org/drawingml/2006/main">
             <a:pPr>
+              <a:buNone/>
               <a:defRPr sz="2475" b="1">
                 <a:solidFill>
                   <a:srgbClr val="25303B"/>
@@ -4039,7 +4218,7 @@
                 <a:ea typeface="Heiti TC"/>
                 <a:cs typeface="Heiti TC"/>
               </a:rPr>
-              <a:t>凝結 → 聚合 → 降落</a:t>
+              <a:t>雲滴聚在一起，變成雨</a:t>
             </a:r>
           </a:p>
         </p:txBody>
@@ -4078,6 +4257,7 @@
           <a:lstStyle xmlns:a="http://schemas.openxmlformats.org/drawingml/2006/main"/>
           <a:p xmlns:a="http://schemas.openxmlformats.org/drawingml/2006/main">
             <a:pPr>
+              <a:buNone/>
               <a:defRPr sz="1950" b="0">
                 <a:solidFill>
                   <a:srgbClr val="3D4F61"/>
@@ -4101,6 +4281,7 @@
           </a:p>
           <a:p xmlns:a="http://schemas.openxmlformats.org/drawingml/2006/main">
             <a:pPr>
+              <a:buNone/>
               <a:defRPr sz="1950" b="0">
                 <a:solidFill>
                   <a:srgbClr val="3D4F61"/>
@@ -4119,11 +4300,12 @@
                 <a:ea typeface="Heiti TC"/>
                 <a:cs typeface="Heiti TC"/>
               </a:rPr>
-              <a:t>水回到天空的循環，</a:t>
-            </a:r>
-          </a:p>
-          <a:p xmlns:a="http://schemas.openxmlformats.org/drawingml/2006/main">
-            <a:pPr>
+              <a:t>我想把這個過程放進花園，</a:t>
+            </a:r>
+          </a:p>
+          <a:p xmlns:a="http://schemas.openxmlformats.org/drawingml/2006/main">
+            <a:pPr>
+              <a:buNone/>
               <a:defRPr sz="1950" b="0">
                 <a:solidFill>
                   <a:srgbClr val="3D4F61"/>
@@ -4142,7 +4324,7 @@
                 <a:ea typeface="Heiti TC"/>
                 <a:cs typeface="Heiti TC"/>
               </a:rPr>
-              <a:t>不等於生命也能自動回去。</a:t>
+              <a:t>讓它有聚集，也有散開和墜落。</a:t>
             </a:r>
           </a:p>
         </p:txBody>
@@ -4181,6 +4363,7 @@
           <a:lstStyle xmlns:a="http://schemas.openxmlformats.org/drawingml/2006/main"/>
           <a:p xmlns:a="http://schemas.openxmlformats.org/drawingml/2006/main">
             <a:pPr>
+              <a:buNone/>
               <a:defRPr sz="1425" b="0">
                 <a:solidFill>
                   <a:srgbClr val="657282"/>
@@ -4200,29 +4383,6 @@
                 <a:cs typeface="Heiti TC"/>
               </a:rPr>
               <a:t>Met Office：The water cycle [5]</a:t>
-            </a:r>
-          </a:p>
-          <a:p xmlns:a="http://schemas.openxmlformats.org/drawingml/2006/main">
-            <a:pPr>
-              <a:defRPr sz="1425" b="0">
-                <a:solidFill>
-                  <a:srgbClr val="657282"/>
-                </a:solidFill>
-                <a:latin typeface="Heiti TC"/>
-                <a:ea typeface="Heiti TC"/>
-                <a:cs typeface="Heiti TC"/>
-              </a:defRPr>
-            </a:pPr>
-            <a:r>
-              <a:rPr sz="1425" b="0">
-                <a:solidFill>
-                  <a:srgbClr val="657282"/>
-                </a:solidFill>
-                <a:latin typeface="Heiti TC"/>
-                <a:ea typeface="Heiti TC"/>
-                <a:cs typeface="Heiti TC"/>
-              </a:rPr>
-              <a:t>氣膠存活限制：Amato et al., 2015 [7]</a:t>
             </a:r>
           </a:p>
         </p:txBody>
@@ -4290,6 +4450,7 @@
           <a:lstStyle xmlns:a="http://schemas.openxmlformats.org/drawingml/2006/main"/>
           <a:p xmlns:a="http://schemas.openxmlformats.org/drawingml/2006/main">
             <a:pPr>
+              <a:buNone/>
               <a:defRPr sz="1350" b="0">
                 <a:solidFill>
                   <a:srgbClr val="818F9F"/>
@@ -4308,7 +4469,7 @@
                 <a:ea typeface="Heiti TC"/>
                 <a:cs typeface="Heiti TC"/>
               </a:rPr>
-              <a:t>M1 / 後未來動物園     未來生命的可能性</a:t>
+              <a:t>M1 / 後未來動物園     花園的樣子</a:t>
             </a:r>
           </a:p>
         </p:txBody>
@@ -4347,6 +4508,7 @@
           <a:lstStyle xmlns:a="http://schemas.openxmlformats.org/drawingml/2006/main"/>
           <a:p xmlns:a="http://schemas.openxmlformats.org/drawingml/2006/main">
             <a:pPr>
+              <a:buNone/>
               <a:defRPr sz="3900" b="0">
                 <a:solidFill>
                   <a:srgbClr val="E9EDF1"/>
@@ -4365,7 +4527,7 @@
                 <a:ea typeface="Heiti TC"/>
                 <a:cs typeface="Heiti TC"/>
               </a:rPr>
-              <a:t>先定世界的規則，再決定生命的樣子</a:t>
+              <a:t>我想呈現的漂浮花園</a:t>
             </a:r>
           </a:p>
         </p:txBody>
@@ -4404,6 +4566,7 @@
           <a:lstStyle xmlns:a="http://schemas.openxmlformats.org/drawingml/2006/main"/>
           <a:p xmlns:a="http://schemas.openxmlformats.org/drawingml/2006/main">
             <a:pPr>
+              <a:buNone/>
               <a:defRPr sz="1275" b="0">
                 <a:solidFill>
                   <a:srgbClr val="818F9F"/>
@@ -4461,6 +4624,7 @@
           <a:lstStyle xmlns:a="http://schemas.openxmlformats.org/drawingml/2006/main"/>
           <a:p xmlns:a="http://schemas.openxmlformats.org/drawingml/2006/main">
             <a:pPr>
+              <a:buNone/>
               <a:defRPr sz="1500" b="0">
                 <a:solidFill>
                   <a:srgbClr val="818F9F"/>
@@ -4518,6 +4682,7 @@
           <a:lstStyle xmlns:a="http://schemas.openxmlformats.org/drawingml/2006/main"/>
           <a:p xmlns:a="http://schemas.openxmlformats.org/drawingml/2006/main">
             <a:pPr>
+              <a:buNone/>
               <a:defRPr sz="2175" b="0">
                 <a:solidFill>
                   <a:srgbClr val="A8BDD2"/>
@@ -4536,7 +4701,7 @@
                 <a:ea typeface="Heiti TC"/>
                 <a:cs typeface="Heiti TC"/>
               </a:rPr>
-              <a:t>生存</a:t>
+              <a:t>材質</a:t>
             </a:r>
           </a:p>
         </p:txBody>
@@ -4575,6 +4740,7 @@
           <a:lstStyle xmlns:a="http://schemas.openxmlformats.org/drawingml/2006/main"/>
           <a:p xmlns:a="http://schemas.openxmlformats.org/drawingml/2006/main">
             <a:pPr>
+              <a:buNone/>
               <a:defRPr sz="2400" b="1">
                 <a:solidFill>
                   <a:srgbClr val="E9EDF1"/>
@@ -4593,7 +4759,7 @@
                 <a:ea typeface="Heiti TC"/>
                 <a:cs typeface="Heiti TC"/>
               </a:rPr>
-              <a:t>水分窗口有限</a:t>
+              <a:t>透明、脆弱</a:t>
             </a:r>
           </a:p>
         </p:txBody>
@@ -4632,7 +4798,8 @@
           <a:lstStyle xmlns:a="http://schemas.openxmlformats.org/drawingml/2006/main"/>
           <a:p xmlns:a="http://schemas.openxmlformats.org/drawingml/2006/main">
             <a:pPr>
-              <a:defRPr sz="1875" b="0">
+              <a:buNone/>
+              <a:defRPr sz="1725" b="0">
                 <a:solidFill>
                   <a:srgbClr val="E9EDF1"/>
                 </a:solidFill>
@@ -4642,7 +4809,7 @@
               </a:defRPr>
             </a:pPr>
             <a:r>
-              <a:rPr sz="1875" b="0">
+              <a:rPr sz="1725" b="0">
                 <a:solidFill>
                   <a:srgbClr val="E9EDF1"/>
                 </a:solidFill>
@@ -4650,12 +4817,13 @@
                 <a:ea typeface="Heiti TC"/>
                 <a:cs typeface="Heiti TC"/>
               </a:rPr>
-              <a:t>溶解有機物是研究起點；</a:t>
-            </a:r>
-          </a:p>
-          <a:p xmlns:a="http://schemas.openxmlformats.org/drawingml/2006/main">
-            <a:pPr>
-              <a:defRPr sz="1875" b="0">
+              <a:t>我想用透明薄膜和結晶，</a:t>
+            </a:r>
+          </a:p>
+          <a:p xmlns:a="http://schemas.openxmlformats.org/drawingml/2006/main">
+            <a:pPr>
+              <a:buNone/>
+              <a:defRPr sz="1725" b="0">
                 <a:solidFill>
                   <a:srgbClr val="E9EDF1"/>
                 </a:solidFill>
@@ -4665,7 +4833,7 @@
               </a:defRPr>
             </a:pPr>
             <a:r>
-              <a:rPr sz="1875" b="0">
+              <a:rPr sz="1725" b="0">
                 <a:solidFill>
                   <a:srgbClr val="E9EDF1"/>
                 </a:solidFill>
@@ -4673,7 +4841,7 @@
                 <a:ea typeface="Heiti TC"/>
                 <a:cs typeface="Heiti TC"/>
               </a:rPr>
-              <a:t>風是運輸方式，不是食物。</a:t>
+              <a:t>讓花園看起來輕薄、脆弱。</a:t>
             </a:r>
           </a:p>
         </p:txBody>
@@ -4712,6 +4880,7 @@
           <a:lstStyle xmlns:a="http://schemas.openxmlformats.org/drawingml/2006/main"/>
           <a:p xmlns:a="http://schemas.openxmlformats.org/drawingml/2006/main">
             <a:pPr>
+              <a:buNone/>
               <a:defRPr sz="2175" b="0">
                 <a:solidFill>
                   <a:srgbClr val="A8BDD2"/>
@@ -4730,7 +4899,7 @@
                 <a:ea typeface="Heiti TC"/>
                 <a:cs typeface="Heiti TC"/>
               </a:rPr>
-              <a:t>棲息</a:t>
+              <a:t>動態</a:t>
             </a:r>
           </a:p>
         </p:txBody>
@@ -4769,6 +4938,7 @@
           <a:lstStyle xmlns:a="http://schemas.openxmlformats.org/drawingml/2006/main"/>
           <a:p xmlns:a="http://schemas.openxmlformats.org/drawingml/2006/main">
             <a:pPr>
+              <a:buNone/>
               <a:defRPr sz="2400" b="1">
                 <a:solidFill>
                   <a:srgbClr val="E9EDF1"/>
@@ -4787,7 +4957,7 @@
                 <a:ea typeface="Heiti TC"/>
                 <a:cs typeface="Heiti TC"/>
               </a:rPr>
-              <a:t>聚合與分散的取捨</a:t>
+              <a:t>漂移、聚散</a:t>
             </a:r>
           </a:p>
         </p:txBody>
@@ -4826,7 +4996,8 @@
           <a:lstStyle xmlns:a="http://schemas.openxmlformats.org/drawingml/2006/main"/>
           <a:p xmlns:a="http://schemas.openxmlformats.org/drawingml/2006/main">
             <a:pPr>
-              <a:defRPr sz="1875" b="0">
+              <a:buNone/>
+              <a:defRPr sz="1725" b="0">
                 <a:solidFill>
                   <a:srgbClr val="E9EDF1"/>
                 </a:solidFill>
@@ -4836,7 +5007,7 @@
               </a:defRPr>
             </a:pPr>
             <a:r>
-              <a:rPr sz="1875" b="0">
+              <a:rPr sz="1725" b="0">
                 <a:solidFill>
                   <a:srgbClr val="E9EDF1"/>
                 </a:solidFill>
@@ -4844,12 +5015,13 @@
                 <a:ea typeface="Heiti TC"/>
                 <a:cs typeface="Heiti TC"/>
               </a:rPr>
-              <a:t>聚集可能提供防護，</a:t>
-            </a:r>
-          </a:p>
-          <a:p xmlns:a="http://schemas.openxmlformats.org/drawingml/2006/main">
-            <a:pPr>
-              <a:defRPr sz="1875" b="0">
+              <a:t>花園可以離開原來的位置，</a:t>
+            </a:r>
+          </a:p>
+          <a:p xmlns:a="http://schemas.openxmlformats.org/drawingml/2006/main">
+            <a:pPr>
+              <a:buNone/>
+              <a:defRPr sz="1725" b="0">
                 <a:solidFill>
                   <a:srgbClr val="E9EDF1"/>
                 </a:solidFill>
@@ -4859,7 +5031,7 @@
               </a:defRPr>
             </a:pPr>
             <a:r>
-              <a:rPr sz="1875" b="0">
+              <a:rPr sz="1725" b="0">
                 <a:solidFill>
                   <a:srgbClr val="E9EDF1"/>
                 </a:solidFill>
@@ -4867,7 +5039,7 @@
                 <a:ea typeface="Heiti TC"/>
                 <a:cs typeface="Heiti TC"/>
               </a:rPr>
-              <a:t>也可能增加沉降與資源競爭。</a:t>
+              <a:t>隨雲移動，再隨雨散開。</a:t>
             </a:r>
           </a:p>
         </p:txBody>
@@ -4906,6 +5078,7 @@
           <a:lstStyle xmlns:a="http://schemas.openxmlformats.org/drawingml/2006/main"/>
           <a:p xmlns:a="http://schemas.openxmlformats.org/drawingml/2006/main">
             <a:pPr>
+              <a:buNone/>
               <a:defRPr sz="2175" b="0">
                 <a:solidFill>
                   <a:srgbClr val="A8BDD2"/>
@@ -4924,7 +5097,7 @@
                 <a:ea typeface="Heiti TC"/>
                 <a:cs typeface="Heiti TC"/>
               </a:rPr>
-              <a:t>繁殖</a:t>
+              <a:t>氣氛</a:t>
             </a:r>
           </a:p>
         </p:txBody>
@@ -4963,6 +5136,7 @@
           <a:lstStyle xmlns:a="http://schemas.openxmlformats.org/drawingml/2006/main"/>
           <a:p xmlns:a="http://schemas.openxmlformats.org/drawingml/2006/main">
             <a:pPr>
+              <a:buNone/>
               <a:defRPr sz="2400" b="1">
                 <a:solidFill>
                   <a:srgbClr val="E9EDF1"/>
@@ -4981,7 +5155,7 @@
                 <a:ea typeface="Heiti TC"/>
                 <a:cs typeface="Heiti TC"/>
               </a:rPr>
-              <a:t>時機比數量更重要</a:t>
+              <a:t>夢幻又詭異</a:t>
             </a:r>
           </a:p>
         </p:txBody>
@@ -5020,7 +5194,8 @@
           <a:lstStyle xmlns:a="http://schemas.openxmlformats.org/drawingml/2006/main"/>
           <a:p xmlns:a="http://schemas.openxmlformats.org/drawingml/2006/main">
             <a:pPr>
-              <a:defRPr sz="1875" b="0">
+              <a:buNone/>
+              <a:defRPr sz="1725" b="0">
                 <a:solidFill>
                   <a:srgbClr val="E9EDF1"/>
                 </a:solidFill>
@@ -5030,7 +5205,7 @@
               </a:defRPr>
             </a:pPr>
             <a:r>
-              <a:rPr sz="1875" b="0">
+              <a:rPr sz="1725" b="0">
                 <a:solidFill>
                   <a:srgbClr val="E9EDF1"/>
                 </a:solidFill>
@@ -5038,12 +5213,13 @@
                 <a:ea typeface="Heiti TC"/>
                 <a:cs typeface="Heiti TC"/>
               </a:rPr>
-              <a:t>快增殖或投入耐受階段？</a:t>
-            </a:r>
-          </a:p>
-          <a:p xmlns:a="http://schemas.openxmlformats.org/drawingml/2006/main">
-            <a:pPr>
-              <a:defRPr sz="1875" b="0">
+              <a:t>光線忽明忽暗，</a:t>
+            </a:r>
+          </a:p>
+          <a:p xmlns:a="http://schemas.openxmlformats.org/drawingml/2006/main">
+            <a:pPr>
+              <a:buNone/>
+              <a:defRPr sz="1725" b="0">
                 <a:solidFill>
                   <a:srgbClr val="E9EDF1"/>
                 </a:solidFill>
@@ -5053,7 +5229,7 @@
               </a:defRPr>
             </a:pPr>
             <a:r>
-              <a:rPr sz="1875" b="0">
+              <a:rPr sz="1725" b="0">
                 <a:solidFill>
                   <a:srgbClr val="E9EDF1"/>
                 </a:solidFill>
@@ -5061,7 +5237,7 @@
                 <a:ea typeface="Heiti TC"/>
                 <a:cs typeface="Heiti TC"/>
               </a:rPr>
-              <a:t>保留到 M2 研究與選擇。</a:t>
+              <a:t>花園的輪廓也跟著變得模糊。</a:t>
             </a:r>
           </a:p>
         </p:txBody>
@@ -5100,6 +5276,7 @@
           <a:lstStyle xmlns:a="http://schemas.openxmlformats.org/drawingml/2006/main"/>
           <a:p xmlns:a="http://schemas.openxmlformats.org/drawingml/2006/main">
             <a:pPr>
+              <a:buNone/>
               <a:defRPr sz="1650" b="0">
                 <a:solidFill>
                   <a:srgbClr val="A8BDD2"/>
@@ -5118,7 +5295,7 @@
                 <a:ea typeface="Heiti TC"/>
                 <a:cs typeface="Heiti TC"/>
               </a:rPr>
-              <a:t>創作設定｜整座花園的自由漂移仍待交代物理機制；本階段不鎖定物種。</a:t>
+              <a:t>目前的構想以花園整體的環境、材質與移動方式為主。</a:t>
             </a:r>
           </a:p>
         </p:txBody>
@@ -5186,6 +5363,7 @@
           <a:lstStyle xmlns:a="http://schemas.openxmlformats.org/drawingml/2006/main"/>
           <a:p xmlns:a="http://schemas.openxmlformats.org/drawingml/2006/main">
             <a:pPr>
+              <a:buNone/>
               <a:defRPr sz="1350" b="0">
                 <a:solidFill>
                   <a:srgbClr val="818F9F"/>
@@ -5204,7 +5382,7 @@
                 <a:ea typeface="Heiti TC"/>
                 <a:cs typeface="Heiti TC"/>
               </a:rPr>
-              <a:t>M1 / 後未來動物園     查證與下一步</a:t>
+              <a:t>M1 / 後未來動物園     作品方向與參考資料</a:t>
             </a:r>
           </a:p>
         </p:txBody>
@@ -5243,6 +5421,7 @@
           <a:lstStyle xmlns:a="http://schemas.openxmlformats.org/drawingml/2006/main"/>
           <a:p xmlns:a="http://schemas.openxmlformats.org/drawingml/2006/main">
             <a:pPr>
+              <a:buNone/>
               <a:defRPr sz="3900" b="0">
                 <a:solidFill>
                   <a:srgbClr val="25303B"/>
@@ -5261,7 +5440,7 @@
                 <a:ea typeface="Heiti TC"/>
                 <a:cs typeface="Heiti TC"/>
               </a:rPr>
-              <a:t>讓想像更自由，也讓依據更清楚</a:t>
+              <a:t>一座不固定在原地的花園</a:t>
             </a:r>
           </a:p>
         </p:txBody>
@@ -5300,6 +5479,7 @@
           <a:lstStyle xmlns:a="http://schemas.openxmlformats.org/drawingml/2006/main"/>
           <a:p xmlns:a="http://schemas.openxmlformats.org/drawingml/2006/main">
             <a:pPr>
+              <a:buNone/>
               <a:defRPr sz="1275" b="0">
                 <a:solidFill>
                   <a:srgbClr val="818F9F"/>
@@ -5357,6 +5537,7 @@
           <a:lstStyle xmlns:a="http://schemas.openxmlformats.org/drawingml/2006/main"/>
           <a:p xmlns:a="http://schemas.openxmlformats.org/drawingml/2006/main">
             <a:pPr>
+              <a:buNone/>
               <a:defRPr sz="1500" b="0">
                 <a:solidFill>
                   <a:srgbClr val="818F9F"/>
@@ -5414,6 +5595,7 @@
           <a:lstStyle xmlns:a="http://schemas.openxmlformats.org/drawingml/2006/main"/>
           <a:p xmlns:a="http://schemas.openxmlformats.org/drawingml/2006/main">
             <a:pPr>
+              <a:buNone/>
               <a:defRPr sz="2325" b="1">
                 <a:solidFill>
                   <a:srgbClr val="25303B"/>
@@ -5432,7 +5614,7 @@
                 <a:ea typeface="Heiti TC"/>
                 <a:cs typeface="Heiti TC"/>
               </a:rPr>
-              <a:t>卡點：微生物證據，能推多遠？</a:t>
+              <a:t>最吸引我的是它可以自由移動</a:t>
             </a:r>
           </a:p>
         </p:txBody>
@@ -5454,24 +5636,25 @@
         <p:spPr>
           <a:xfrm xmlns:a="http://schemas.openxmlformats.org/drawingml/2006/main">
             <a:off x="638175" y="2790825"/>
-            <a:ext cx="5715000" cy="1400175"/>
-          </a:xfrm>
-          <a:prstGeom xmlns:a="http://schemas.openxmlformats.org/drawingml/2006/main" prst="rect">
-            <a:avLst/>
-          </a:prstGeom>
-          <a:noFill xmlns:a="http://schemas.openxmlformats.org/drawingml/2006/main"/>
-          <a:ln xmlns:a="http://schemas.openxmlformats.org/drawingml/2006/main" w="0">
-            <a:noFill/>
-          </a:ln>
-        </p:spPr>
-        <p:txBody>
-          <a:bodyPr xmlns:a="http://schemas.openxmlformats.org/drawingml/2006/main">
-            <a:noAutofit/>
-          </a:bodyPr>
-          <a:lstStyle xmlns:a="http://schemas.openxmlformats.org/drawingml/2006/main"/>
-          <a:p xmlns:a="http://schemas.openxmlformats.org/drawingml/2006/main">
-            <a:pPr>
-              <a:defRPr sz="1950" b="0">
+            <a:ext cx="5715000" cy="1809750"/>
+          </a:xfrm>
+          <a:prstGeom xmlns:a="http://schemas.openxmlformats.org/drawingml/2006/main" prst="rect">
+            <a:avLst/>
+          </a:prstGeom>
+          <a:noFill xmlns:a="http://schemas.openxmlformats.org/drawingml/2006/main"/>
+          <a:ln xmlns:a="http://schemas.openxmlformats.org/drawingml/2006/main" w="0">
+            <a:noFill/>
+          </a:ln>
+        </p:spPr>
+        <p:txBody>
+          <a:bodyPr xmlns:a="http://schemas.openxmlformats.org/drawingml/2006/main">
+            <a:noAutofit/>
+          </a:bodyPr>
+          <a:lstStyle xmlns:a="http://schemas.openxmlformats.org/drawingml/2006/main"/>
+          <a:p xmlns:a="http://schemas.openxmlformats.org/drawingml/2006/main">
+            <a:pPr>
+              <a:buNone/>
+              <a:defRPr sz="1875" b="0">
                 <a:solidFill>
                   <a:srgbClr val="3D4F61"/>
                 </a:solidFill>
@@ -5481,7 +5664,7 @@
               </a:defRPr>
             </a:pPr>
             <a:r>
-              <a:rPr sz="1950" b="0">
+              <a:rPr sz="1875" b="0">
                 <a:solidFill>
                   <a:srgbClr val="3D4F61"/>
                 </a:solidFill>
@@ -5489,12 +5672,13 @@
                 <a:ea typeface="Heiti TC"/>
                 <a:cs typeface="Heiti TC"/>
               </a:rPr>
-              <a:t>回原文讀取樣條件與研究限制，</a:t>
-            </a:r>
-          </a:p>
-          <a:p xmlns:a="http://schemas.openxmlformats.org/drawingml/2006/main">
-            <a:pPr>
-              <a:defRPr sz="1950" b="0">
+              <a:t>我喜歡花園不必停在同一個地方，</a:t>
+            </a:r>
+          </a:p>
+          <a:p xmlns:a="http://schemas.openxmlformats.org/drawingml/2006/main">
+            <a:pPr>
+              <a:buNone/>
+              <a:defRPr sz="1875" b="0">
                 <a:solidFill>
                   <a:srgbClr val="3D4F61"/>
                 </a:solidFill>
@@ -5504,7 +5688,7 @@
               </a:defRPr>
             </a:pPr>
             <a:r>
-              <a:rPr sz="1950" b="0">
+              <a:rPr sz="1875" b="0">
                 <a:solidFill>
                   <a:srgbClr val="3D4F61"/>
                 </a:solidFill>
@@ -5512,7 +5696,7 @@
                 <a:ea typeface="Heiti TC"/>
                 <a:cs typeface="Heiti TC"/>
               </a:rPr>
-              <a:t>再找獨立研究交叉對照。</a:t>
+              <a:t>而是隨著環境改變的想像。</a:t>
             </a:r>
           </a:p>
           <a:p xmlns:a="http://schemas.openxmlformats.org/drawingml/2006/main">
@@ -5522,7 +5706,8 @@
           </a:p>
           <a:p xmlns:a="http://schemas.openxmlformats.org/drawingml/2006/main">
             <a:pPr>
-              <a:defRPr sz="1950" b="0">
+              <a:buNone/>
+              <a:defRPr sz="1875" b="0">
                 <a:solidFill>
                   <a:srgbClr val="3D4F61"/>
                 </a:solidFill>
@@ -5532,7 +5717,7 @@
               </a:defRPr>
             </a:pPr>
             <a:r>
-              <a:rPr sz="1950" b="0">
+              <a:rPr sz="1875" b="0">
                 <a:solidFill>
                   <a:srgbClr val="3D4F61"/>
                 </a:solidFill>
@@ -5540,7 +5725,31 @@
                 <a:ea typeface="Heiti TC"/>
                 <a:cs typeface="Heiti TC"/>
               </a:rPr>
-              <a:t>仍需解決：漂浮尺度、能量收支、再入雲。</a:t>
+              <a:t>雲滴的聚散和降雨，</a:t>
+            </a:r>
+          </a:p>
+          <a:p xmlns:a="http://schemas.openxmlformats.org/drawingml/2006/main">
+            <a:pPr>
+              <a:buNone/>
+              <a:defRPr sz="1875" b="0">
+                <a:solidFill>
+                  <a:srgbClr val="3D4F61"/>
+                </a:solidFill>
+                <a:latin typeface="Heiti TC"/>
+                <a:ea typeface="Heiti TC"/>
+                <a:cs typeface="Heiti TC"/>
+              </a:defRPr>
+            </a:pPr>
+            <a:r>
+              <a:rPr sz="1875" b="0">
+                <a:solidFill>
+                  <a:srgbClr val="3D4F61"/>
+                </a:solidFill>
+                <a:latin typeface="Heiti TC"/>
+                <a:ea typeface="Heiti TC"/>
+                <a:cs typeface="Heiti TC"/>
+              </a:rPr>
+              <a:t>成為這個世界的動態參考。</a:t>
             </a:r>
           </a:p>
         </p:txBody>
@@ -5579,6 +5788,7 @@
           <a:lstStyle xmlns:a="http://schemas.openxmlformats.org/drawingml/2006/main"/>
           <a:p xmlns:a="http://schemas.openxmlformats.org/drawingml/2006/main">
             <a:pPr>
+              <a:buNone/>
               <a:defRPr sz="1950" b="0">
                 <a:solidFill>
                   <a:srgbClr val="3D4F61"/>
@@ -5597,11 +5807,12 @@
                 <a:ea typeface="Heiti TC"/>
                 <a:cs typeface="Heiti TC"/>
               </a:rPr>
-              <a:t>下一站：從「移動的棲地」出發，</a:t>
-            </a:r>
-          </a:p>
-          <a:p xmlns:a="http://schemas.openxmlformats.org/drawingml/2006/main">
-            <a:pPr>
+              <a:t>目前已整理世界的環境研究，</a:t>
+            </a:r>
+          </a:p>
+          <a:p xmlns:a="http://schemas.openxmlformats.org/drawingml/2006/main">
+            <a:pPr>
+              <a:buNone/>
               <a:defRPr sz="1950" b="0">
                 <a:solidFill>
                   <a:srgbClr val="3D4F61"/>
@@ -5620,7 +5831,7 @@
                 <a:ea typeface="Heiti TC"/>
                 <a:cs typeface="Heiti TC"/>
               </a:rPr>
-              <a:t>探索保護層、聚散與墜落。</a:t>
+              <a:t>以及想用在建模與動態中的方向。</a:t>
             </a:r>
           </a:p>
         </p:txBody>
@@ -5659,6 +5870,7 @@
           <a:lstStyle xmlns:a="http://schemas.openxmlformats.org/drawingml/2006/main"/>
           <a:p xmlns:a="http://schemas.openxmlformats.org/drawingml/2006/main">
             <a:pPr>
+              <a:buNone/>
               <a:defRPr sz="1725" b="1">
                 <a:solidFill>
                   <a:srgbClr val="25303B"/>
@@ -5677,7 +5889,7 @@
                 <a:ea typeface="Heiti TC"/>
                 <a:cs typeface="Heiti TC"/>
               </a:rPr>
-              <a:t>主要來源</a:t>
+              <a:t>參考資料</a:t>
             </a:r>
           </a:p>
         </p:txBody>
@@ -5716,6 +5928,7 @@
           <a:lstStyle xmlns:a="http://schemas.openxmlformats.org/drawingml/2006/main"/>
           <a:p xmlns:a="http://schemas.openxmlformats.org/drawingml/2006/main">
             <a:pPr>
+              <a:buNone/>
               <a:defRPr sz="1350" b="0">
                 <a:solidFill>
                   <a:srgbClr val="657282"/>
@@ -5739,6 +5952,7 @@
           </a:p>
           <a:p xmlns:a="http://schemas.openxmlformats.org/drawingml/2006/main">
             <a:pPr>
+              <a:buNone/>
               <a:defRPr sz="1350" b="0">
                 <a:solidFill>
                   <a:srgbClr val="657282"/>
@@ -5796,6 +6010,7 @@
           <a:lstStyle xmlns:a="http://schemas.openxmlformats.org/drawingml/2006/main"/>
           <a:p xmlns:a="http://schemas.openxmlformats.org/drawingml/2006/main">
             <a:pPr>
+              <a:buNone/>
               <a:defRPr sz="1350" b="0">
                 <a:solidFill>
                   <a:srgbClr val="657282"/>
@@ -5819,6 +6034,7 @@
           </a:p>
           <a:p xmlns:a="http://schemas.openxmlformats.org/drawingml/2006/main">
             <a:pPr>
+              <a:buNone/>
               <a:defRPr sz="1350" b="0">
                 <a:solidFill>
                   <a:srgbClr val="657282"/>
@@ -5876,6 +6092,7 @@
           <a:lstStyle xmlns:a="http://schemas.openxmlformats.org/drawingml/2006/main"/>
           <a:p xmlns:a="http://schemas.openxmlformats.org/drawingml/2006/main">
             <a:pPr>
+              <a:buNone/>
               <a:defRPr sz="1350" b="0">
                 <a:solidFill>
                   <a:srgbClr val="657282"/>
@@ -5899,6 +6116,7 @@
           </a:p>
           <a:p xmlns:a="http://schemas.openxmlformats.org/drawingml/2006/main">
             <a:pPr>
+              <a:buNone/>
               <a:defRPr sz="1350" b="0">
                 <a:solidFill>
                   <a:srgbClr val="657282"/>
@@ -5956,6 +6174,7 @@
           <a:lstStyle xmlns:a="http://schemas.openxmlformats.org/drawingml/2006/main"/>
           <a:p xmlns:a="http://schemas.openxmlformats.org/drawingml/2006/main">
             <a:pPr>
+              <a:buNone/>
               <a:defRPr sz="1350" b="0">
                 <a:solidFill>
                   <a:srgbClr val="657282"/>
@@ -5979,6 +6198,7 @@
           </a:p>
           <a:p xmlns:a="http://schemas.openxmlformats.org/drawingml/2006/main">
             <a:pPr>
+              <a:buNone/>
               <a:defRPr sz="1350" b="0">
                 <a:solidFill>
                   <a:srgbClr val="657282"/>
@@ -6036,6 +6256,7 @@
           <a:lstStyle xmlns:a="http://schemas.openxmlformats.org/drawingml/2006/main"/>
           <a:p xmlns:a="http://schemas.openxmlformats.org/drawingml/2006/main">
             <a:pPr>
+              <a:buNone/>
               <a:defRPr sz="1350" b="0">
                 <a:solidFill>
                   <a:srgbClr val="657282"/>
@@ -6054,11 +6275,12 @@
                 <a:ea typeface="Heiti TC"/>
                 <a:cs typeface="Heiti TC"/>
               </a:rPr>
-              <a:t>[5] Met Office · The water cycle</a:t>
-            </a:r>
-          </a:p>
-          <a:p xmlns:a="http://schemas.openxmlformats.org/drawingml/2006/main">
-            <a:pPr>
+              <a:t>[5] Met Office</a:t>
+            </a:r>
+          </a:p>
+          <a:p xmlns:a="http://schemas.openxmlformats.org/drawingml/2006/main">
+            <a:pPr>
+              <a:buNone/>
               <a:defRPr sz="1350" b="0">
                 <a:solidFill>
                   <a:srgbClr val="657282"/>
@@ -6077,11 +6299,12 @@
                 <a:ea typeface="Heiti TC"/>
                 <a:cs typeface="Heiti TC"/>
               </a:rPr>
-              <a:t>[7] Amato et al. 2015 · ACP</a:t>
-            </a:r>
-          </a:p>
-          <a:p xmlns:a="http://schemas.openxmlformats.org/drawingml/2006/main">
-            <a:pPr>
+              <a:t>The water cycle</a:t>
+            </a:r>
+          </a:p>
+          <a:p xmlns:a="http://schemas.openxmlformats.org/drawingml/2006/main">
+            <a:pPr>
+              <a:buNone/>
               <a:defRPr sz="1350" b="0">
                 <a:solidFill>
                   <a:srgbClr val="657282"/>
@@ -6100,7 +6323,7 @@
                 <a:ea typeface="Heiti TC"/>
                 <a:cs typeface="Heiti TC"/>
               </a:rPr>
-              <a:t>10.5194/acp-15-6455-2015</a:t>
+              <a:t>完整來源收錄於世界觀研究報告。</a:t>
             </a:r>
           </a:p>
         </p:txBody>

</xml_diff>